<commit_message>
Add Story 1 presentation and submission PDF
</commit_message>
<xml_diff>
--- a/story_01_iija/presentation/Muhammad_Suffyan_Khan_DATA608_Story1.pptx
+++ b/story_01_iija/presentation/Muhammad_Suffyan_Khan_DATA608_Story1.pptx
@@ -7303,7 +7303,7 @@
           </a:bodyPr>
           <a:lstStyle/>
           <a:p>
-            <a:pPr algn="l">
+            <a:pPr>
               <a:defRPr sz="1200" b="1">
                 <a:solidFill>
                   <a:srgbClr val="2563EB"/>
@@ -7314,16 +7314,22 @@
               </a:defRPr>
             </a:pPr>
             <a:r>
-              <a:rPr sz="1200" b="1">
+              <a:rPr lang="en-US" sz="1200" b="1">
                 <a:solidFill>
                   <a:srgbClr val="2563EB"/>
                 </a:solidFill>
                 <a:latin typeface="Bitstream Charter"/>
-                <a:ea typeface="Bitstream Charter"/>
-                <a:cs typeface="Bitstream Charter"/>
               </a:rPr>
-              <a:t>Supporting notebook and processed data are maintained in the private course repository.</a:t>
-            </a:r>
+              <a:t>Supporting notebook, processed data, and reproducible analysis are available through the GitHub repository linked in the submission comments.</a:t>
+            </a:r>
+            <a:endParaRPr sz="1200" b="1" dirty="0">
+              <a:solidFill>
+                <a:srgbClr val="2563EB"/>
+              </a:solidFill>
+              <a:latin typeface="Bitstream Charter"/>
+              <a:ea typeface="Bitstream Charter"/>
+              <a:cs typeface="Bitstream Charter"/>
+            </a:endParaRPr>
           </a:p>
         </p:txBody>
       </p:sp>

</xml_diff>